<commit_message>
Added to final presentation
</commit_message>
<xml_diff>
--- a/מצגת סיום.pptx
+++ b/מצגת סיום.pptx
@@ -5,7 +5,7 @@
     <p:sldMasterId id="2147484235" r:id="rId1"/>
   </p:sldMasterIdLst>
   <p:notesMasterIdLst>
-    <p:notesMasterId r:id="rId15"/>
+    <p:notesMasterId r:id="rId18"/>
   </p:notesMasterIdLst>
   <p:sldIdLst>
     <p:sldId id="256" r:id="rId2"/>
@@ -18,9 +18,12 @@
     <p:sldId id="264" r:id="rId9"/>
     <p:sldId id="274" r:id="rId10"/>
     <p:sldId id="262" r:id="rId11"/>
-    <p:sldId id="275" r:id="rId12"/>
-    <p:sldId id="259" r:id="rId13"/>
-    <p:sldId id="265" r:id="rId14"/>
+    <p:sldId id="278" r:id="rId12"/>
+    <p:sldId id="275" r:id="rId13"/>
+    <p:sldId id="259" r:id="rId14"/>
+    <p:sldId id="265" r:id="rId15"/>
+    <p:sldId id="276" r:id="rId16"/>
+    <p:sldId id="277" r:id="rId17"/>
   </p:sldIdLst>
   <p:sldSz cx="12192000" cy="6858000"/>
   <p:notesSz cx="6858000" cy="9144000"/>
@@ -209,7 +212,7 @@
           <a:p>
             <a:fld id="{C2198165-09EB-F44F-8611-B98237520925}" type="datetimeFigureOut">
               <a:rPr lang="en-IL" smtClean="0"/>
-              <a:t>08/03/2025</a:t>
+              <a:t>09/03/2025</a:t>
             </a:fld>
             <a:endParaRPr lang="en-IL"/>
           </a:p>
@@ -840,7 +843,7 @@
           <a:p>
             <a:fld id="{435A84CE-D45A-8043-B857-2B5DEA1CCAAF}" type="datetimeFigureOut">
               <a:rPr lang="en-IL" smtClean="0"/>
-              <a:t>08/03/2025</a:t>
+              <a:t>09/03/2025</a:t>
             </a:fld>
             <a:endParaRPr lang="en-IL"/>
           </a:p>
@@ -1107,7 +1110,7 @@
           <a:p>
             <a:fld id="{435A84CE-D45A-8043-B857-2B5DEA1CCAAF}" type="datetimeFigureOut">
               <a:rPr lang="en-IL" smtClean="0"/>
-              <a:t>08/03/2025</a:t>
+              <a:t>09/03/2025</a:t>
             </a:fld>
             <a:endParaRPr lang="en-IL"/>
           </a:p>
@@ -1338,7 +1341,7 @@
           <a:p>
             <a:fld id="{435A84CE-D45A-8043-B857-2B5DEA1CCAAF}" type="datetimeFigureOut">
               <a:rPr lang="en-IL" smtClean="0"/>
-              <a:t>08/03/2025</a:t>
+              <a:t>09/03/2025</a:t>
             </a:fld>
             <a:endParaRPr lang="en-IL"/>
           </a:p>
@@ -1648,7 +1651,7 @@
           <a:p>
             <a:fld id="{435A84CE-D45A-8043-B857-2B5DEA1CCAAF}" type="datetimeFigureOut">
               <a:rPr lang="en-IL" smtClean="0"/>
-              <a:t>08/03/2025</a:t>
+              <a:t>09/03/2025</a:t>
             </a:fld>
             <a:endParaRPr lang="en-IL"/>
           </a:p>
@@ -2121,7 +2124,7 @@
           <a:p>
             <a:fld id="{435A84CE-D45A-8043-B857-2B5DEA1CCAAF}" type="datetimeFigureOut">
               <a:rPr lang="en-IL" smtClean="0"/>
-              <a:t>08/03/2025</a:t>
+              <a:t>09/03/2025</a:t>
             </a:fld>
             <a:endParaRPr lang="en-IL"/>
           </a:p>
@@ -2668,7 +2671,7 @@
           <a:p>
             <a:fld id="{435A84CE-D45A-8043-B857-2B5DEA1CCAAF}" type="datetimeFigureOut">
               <a:rPr lang="en-IL" smtClean="0"/>
-              <a:t>08/03/2025</a:t>
+              <a:t>09/03/2025</a:t>
             </a:fld>
             <a:endParaRPr lang="en-IL"/>
           </a:p>
@@ -3442,7 +3445,7 @@
           <a:p>
             <a:fld id="{435A84CE-D45A-8043-B857-2B5DEA1CCAAF}" type="datetimeFigureOut">
               <a:rPr lang="en-IL" smtClean="0"/>
-              <a:t>08/03/2025</a:t>
+              <a:t>09/03/2025</a:t>
             </a:fld>
             <a:endParaRPr lang="en-IL"/>
           </a:p>
@@ -3617,7 +3620,7 @@
           <a:p>
             <a:fld id="{435A84CE-D45A-8043-B857-2B5DEA1CCAAF}" type="datetimeFigureOut">
               <a:rPr lang="en-IL" smtClean="0"/>
-              <a:t>08/03/2025</a:t>
+              <a:t>09/03/2025</a:t>
             </a:fld>
             <a:endParaRPr lang="en-IL"/>
           </a:p>
@@ -3840,7 +3843,7 @@
           <a:p>
             <a:fld id="{435A84CE-D45A-8043-B857-2B5DEA1CCAAF}" type="datetimeFigureOut">
               <a:rPr lang="en-IL" smtClean="0"/>
-              <a:t>08/03/2025</a:t>
+              <a:t>09/03/2025</a:t>
             </a:fld>
             <a:endParaRPr lang="en-IL"/>
           </a:p>
@@ -4020,7 +4023,7 @@
           <a:p>
             <a:fld id="{435A84CE-D45A-8043-B857-2B5DEA1CCAAF}" type="datetimeFigureOut">
               <a:rPr lang="en-IL" smtClean="0"/>
-              <a:t>08/03/2025</a:t>
+              <a:t>09/03/2025</a:t>
             </a:fld>
             <a:endParaRPr lang="en-IL"/>
           </a:p>
@@ -4309,7 +4312,7 @@
           <a:p>
             <a:fld id="{435A84CE-D45A-8043-B857-2B5DEA1CCAAF}" type="datetimeFigureOut">
               <a:rPr lang="en-IL" smtClean="0"/>
-              <a:t>08/03/2025</a:t>
+              <a:t>09/03/2025</a:t>
             </a:fld>
             <a:endParaRPr lang="en-IL"/>
           </a:p>
@@ -4551,7 +4554,7 @@
           <a:p>
             <a:fld id="{435A84CE-D45A-8043-B857-2B5DEA1CCAAF}" type="datetimeFigureOut">
               <a:rPr lang="en-IL" smtClean="0"/>
-              <a:t>08/03/2025</a:t>
+              <a:t>09/03/2025</a:t>
             </a:fld>
             <a:endParaRPr lang="en-IL"/>
           </a:p>
@@ -4930,7 +4933,7 @@
           <a:p>
             <a:fld id="{435A84CE-D45A-8043-B857-2B5DEA1CCAAF}" type="datetimeFigureOut">
               <a:rPr lang="en-IL" smtClean="0"/>
-              <a:t>08/03/2025</a:t>
+              <a:t>09/03/2025</a:t>
             </a:fld>
             <a:endParaRPr lang="en-IL"/>
           </a:p>
@@ -5048,7 +5051,7 @@
           <a:p>
             <a:fld id="{435A84CE-D45A-8043-B857-2B5DEA1CCAAF}" type="datetimeFigureOut">
               <a:rPr lang="en-IL" smtClean="0"/>
-              <a:t>08/03/2025</a:t>
+              <a:t>09/03/2025</a:t>
             </a:fld>
             <a:endParaRPr lang="en-IL"/>
           </a:p>
@@ -5143,7 +5146,7 @@
           <a:p>
             <a:fld id="{435A84CE-D45A-8043-B857-2B5DEA1CCAAF}" type="datetimeFigureOut">
               <a:rPr lang="en-IL" smtClean="0"/>
-              <a:t>08/03/2025</a:t>
+              <a:t>09/03/2025</a:t>
             </a:fld>
             <a:endParaRPr lang="en-IL"/>
           </a:p>
@@ -5392,7 +5395,7 @@
           <a:p>
             <a:fld id="{435A84CE-D45A-8043-B857-2B5DEA1CCAAF}" type="datetimeFigureOut">
               <a:rPr lang="en-IL" smtClean="0"/>
-              <a:t>08/03/2025</a:t>
+              <a:t>09/03/2025</a:t>
             </a:fld>
             <a:endParaRPr lang="en-IL"/>
           </a:p>
@@ -5649,7 +5652,7 @@
           <a:p>
             <a:fld id="{435A84CE-D45A-8043-B857-2B5DEA1CCAAF}" type="datetimeFigureOut">
               <a:rPr lang="en-IL" smtClean="0"/>
-              <a:t>08/03/2025</a:t>
+              <a:t>09/03/2025</a:t>
             </a:fld>
             <a:endParaRPr lang="en-IL"/>
           </a:p>
@@ -5892,7 +5895,7 @@
           <a:p>
             <a:fld id="{435A84CE-D45A-8043-B857-2B5DEA1CCAAF}" type="datetimeFigureOut">
               <a:rPr lang="en-IL" smtClean="0"/>
-              <a:t>08/03/2025</a:t>
+              <a:t>09/03/2025</a:t>
             </a:fld>
             <a:endParaRPr lang="en-IL"/>
           </a:p>
@@ -6396,18 +6399,10 @@
               <a:buNone/>
             </a:pPr>
             <a:r>
-              <a:rPr lang="he-IL" dirty="0">
-                <a:highlight>
-                  <a:srgbClr val="FFFF00"/>
-                </a:highlight>
-              </a:rPr>
-              <a:t>דוד לוין </a:t>
-            </a:r>
-            <a:endParaRPr lang="en-IL" dirty="0">
-              <a:highlight>
-                <a:srgbClr val="FFFF00"/>
-              </a:highlight>
-            </a:endParaRPr>
+              <a:rPr lang="he-IL" dirty="0"/>
+              <a:t>דוד לוין 207932526 </a:t>
+            </a:r>
+            <a:endParaRPr lang="en-IL" dirty="0"/>
           </a:p>
         </p:txBody>
       </p:sp>
@@ -6470,7 +6465,7 @@
           <a:p>
             <a:r>
               <a:rPr lang="he-IL" dirty="0"/>
-              <a:t>תיאור השיטה</a:t>
+              <a:t>תיאור השיטה בזמן אמת</a:t>
             </a:r>
             <a:endParaRPr lang="en-IL" dirty="0"/>
           </a:p>
@@ -6502,16 +6497,20 @@
           <a:bodyPr/>
           <a:lstStyle/>
           <a:p>
-            <a:pPr algn="r" rtl="1"/>
-            <a:r>
-              <a:rPr lang="en-US" sz="1800" u="sng" kern="100" dirty="0">
-                <a:effectLst/>
-                <a:latin typeface="Calibri" panose="020F0502020204030204" pitchFamily="34" charset="0"/>
-                <a:ea typeface="DengXian" panose="02010600030101010101" pitchFamily="2" charset="-122"/>
-                <a:cs typeface="Arial" panose="020B0604020202020204" pitchFamily="34" charset="0"/>
-              </a:rPr>
-              <a:t>ONLINE</a:t>
-            </a:r>
+            <a:pPr marL="0" indent="0" algn="r" rtl="1">
+              <a:buNone/>
+            </a:pPr>
+            <a:endParaRPr lang="en-US" sz="1800" kern="100" dirty="0">
+              <a:effectLst/>
+              <a:latin typeface="Calibri" panose="020F0502020204030204" pitchFamily="34" charset="0"/>
+              <a:ea typeface="DengXian" panose="02010600030101010101" pitchFamily="2" charset="-122"/>
+              <a:cs typeface="Arial" panose="020B0604020202020204" pitchFamily="34" charset="0"/>
+            </a:endParaRPr>
+          </a:p>
+          <a:p>
+            <a:pPr marL="0" indent="0" algn="r" rtl="1">
+              <a:buNone/>
+            </a:pPr>
             <a:endParaRPr lang="en-IL" sz="1800" kern="100" dirty="0">
               <a:effectLst/>
               <a:latin typeface="Calibri" panose="020F0502020204030204" pitchFamily="34" charset="0"/>
@@ -6534,6 +6533,66 @@
           </a:p>
         </p:txBody>
       </p:sp>
+      <p:pic>
+        <p:nvPicPr>
+          <p:cNvPr id="5" name="Picture 4">
+            <a:extLst>
+              <a:ext uri="{FF2B5EF4-FFF2-40B4-BE49-F238E27FC236}">
+                <a16:creationId xmlns:a16="http://schemas.microsoft.com/office/drawing/2014/main" id="{3804159F-7DD2-CC43-3C1F-FF298CC7A894}"/>
+              </a:ext>
+            </a:extLst>
+          </p:cNvPr>
+          <p:cNvPicPr>
+            <a:picLocks noChangeAspect="1"/>
+          </p:cNvPicPr>
+          <p:nvPr/>
+        </p:nvPicPr>
+        <p:blipFill>
+          <a:blip r:embed="rId2"/>
+          <a:stretch>
+            <a:fillRect/>
+          </a:stretch>
+        </p:blipFill>
+        <p:spPr>
+          <a:xfrm>
+            <a:off x="2660424" y="2057401"/>
+            <a:ext cx="6049219" cy="2829320"/>
+          </a:xfrm>
+          <a:prstGeom prst="rect">
+            <a:avLst/>
+          </a:prstGeom>
+        </p:spPr>
+      </p:pic>
+      <p:pic>
+        <p:nvPicPr>
+          <p:cNvPr id="7" name="Picture 6">
+            <a:extLst>
+              <a:ext uri="{FF2B5EF4-FFF2-40B4-BE49-F238E27FC236}">
+                <a16:creationId xmlns:a16="http://schemas.microsoft.com/office/drawing/2014/main" id="{DA9F6C9D-D274-FD50-4559-AD0A5B5D85F8}"/>
+              </a:ext>
+            </a:extLst>
+          </p:cNvPr>
+          <p:cNvPicPr>
+            <a:picLocks noChangeAspect="1"/>
+          </p:cNvPicPr>
+          <p:nvPr/>
+        </p:nvPicPr>
+        <p:blipFill>
+          <a:blip r:embed="rId3"/>
+          <a:stretch>
+            <a:fillRect/>
+          </a:stretch>
+        </p:blipFill>
+        <p:spPr>
+          <a:xfrm>
+            <a:off x="3513891" y="5427010"/>
+            <a:ext cx="4629959" cy="666617"/>
+          </a:xfrm>
+          <a:prstGeom prst="rect">
+            <a:avLst/>
+          </a:prstGeom>
+        </p:spPr>
+      </p:pic>
     </p:spTree>
     <p:extLst>
       <p:ext uri="{BB962C8B-B14F-4D97-AF65-F5344CB8AC3E}">
@@ -6548,6 +6607,163 @@
 </file>
 
 <file path=ppt/slides/slide11.xml><?xml version="1.0" encoding="utf-8"?>
+<p:sld xmlns:a="http://schemas.openxmlformats.org/drawingml/2006/main" xmlns:r="http://schemas.openxmlformats.org/officeDocument/2006/relationships" xmlns:p="http://schemas.openxmlformats.org/presentationml/2006/main">
+  <p:cSld>
+    <p:spTree>
+      <p:nvGrpSpPr>
+        <p:cNvPr id="1" name="">
+          <a:extLst>
+            <a:ext uri="{FF2B5EF4-FFF2-40B4-BE49-F238E27FC236}">
+              <a16:creationId xmlns:a16="http://schemas.microsoft.com/office/drawing/2014/main" id="{052F89DD-1423-DB4D-C12F-DD1591217318}"/>
+            </a:ext>
+          </a:extLst>
+        </p:cNvPr>
+        <p:cNvGrpSpPr/>
+        <p:nvPr/>
+      </p:nvGrpSpPr>
+      <p:grpSpPr>
+        <a:xfrm>
+          <a:off x="0" y="0"/>
+          <a:ext cx="0" cy="0"/>
+          <a:chOff x="0" y="0"/>
+          <a:chExt cx="0" cy="0"/>
+        </a:xfrm>
+      </p:grpSpPr>
+      <p:sp>
+        <p:nvSpPr>
+          <p:cNvPr id="2" name="Title 1">
+            <a:extLst>
+              <a:ext uri="{FF2B5EF4-FFF2-40B4-BE49-F238E27FC236}">
+                <a16:creationId xmlns:a16="http://schemas.microsoft.com/office/drawing/2014/main" id="{497DF1DA-F212-1738-A9B5-C76E34F4D1BE}"/>
+              </a:ext>
+            </a:extLst>
+          </p:cNvPr>
+          <p:cNvSpPr>
+            <a:spLocks noGrp="1"/>
+          </p:cNvSpPr>
+          <p:nvPr>
+            <p:ph type="title"/>
+          </p:nvPr>
+        </p:nvSpPr>
+        <p:spPr/>
+        <p:txBody>
+          <a:bodyPr/>
+          <a:lstStyle/>
+          <a:p>
+            <a:r>
+              <a:rPr lang="he-IL" dirty="0"/>
+              <a:t>תיאור השיטה בזמן אמת</a:t>
+            </a:r>
+            <a:endParaRPr lang="en-IL" dirty="0"/>
+          </a:p>
+        </p:txBody>
+      </p:sp>
+      <p:sp>
+        <p:nvSpPr>
+          <p:cNvPr id="3" name="Content Placeholder 2">
+            <a:extLst>
+              <a:ext uri="{FF2B5EF4-FFF2-40B4-BE49-F238E27FC236}">
+                <a16:creationId xmlns:a16="http://schemas.microsoft.com/office/drawing/2014/main" id="{29E98F99-D93A-3576-5DF0-93171F2872A8}"/>
+              </a:ext>
+            </a:extLst>
+          </p:cNvPr>
+          <p:cNvSpPr>
+            <a:spLocks noGrp="1"/>
+          </p:cNvSpPr>
+          <p:nvPr>
+            <p:ph idx="1"/>
+          </p:nvPr>
+        </p:nvSpPr>
+        <p:spPr>
+          <a:xfrm>
+            <a:off x="838200" y="1602341"/>
+            <a:ext cx="10515600" cy="4351338"/>
+          </a:xfrm>
+        </p:spPr>
+        <p:txBody>
+          <a:bodyPr/>
+          <a:lstStyle/>
+          <a:p>
+            <a:pPr marL="0" indent="0" algn="r" rtl="1">
+              <a:buNone/>
+            </a:pPr>
+            <a:endParaRPr lang="en-US" sz="1800" kern="100" dirty="0">
+              <a:effectLst/>
+              <a:latin typeface="Calibri" panose="020F0502020204030204" pitchFamily="34" charset="0"/>
+              <a:ea typeface="DengXian" panose="02010600030101010101" pitchFamily="2" charset="-122"/>
+              <a:cs typeface="Arial" panose="020B0604020202020204" pitchFamily="34" charset="0"/>
+            </a:endParaRPr>
+          </a:p>
+          <a:p>
+            <a:pPr marL="0" indent="0" algn="r" rtl="1">
+              <a:buNone/>
+            </a:pPr>
+            <a:endParaRPr lang="en-IL" sz="1800" kern="100" dirty="0">
+              <a:effectLst/>
+              <a:latin typeface="Calibri" panose="020F0502020204030204" pitchFamily="34" charset="0"/>
+              <a:ea typeface="DengXian" panose="02010600030101010101" pitchFamily="2" charset="-122"/>
+              <a:cs typeface="Arial" panose="020B0604020202020204" pitchFamily="34" charset="0"/>
+            </a:endParaRPr>
+          </a:p>
+          <a:p>
+            <a:pPr marL="228600" indent="-228600" algn="r" defTabSz="914400" rtl="1" eaLnBrk="1" latinLnBrk="0" hangingPunct="1">
+              <a:lnSpc>
+                <a:spcPct val="90000"/>
+              </a:lnSpc>
+              <a:spcBef>
+                <a:spcPts val="1000"/>
+              </a:spcBef>
+              <a:buFont typeface="Arial" panose="020B0604020202020204" pitchFamily="34" charset="0"/>
+              <a:buChar char="•"/>
+            </a:pPr>
+            <a:endParaRPr lang="en-IL" dirty="0"/>
+          </a:p>
+        </p:txBody>
+      </p:sp>
+      <p:pic>
+        <p:nvPicPr>
+          <p:cNvPr id="6" name="Picture 5">
+            <a:extLst>
+              <a:ext uri="{FF2B5EF4-FFF2-40B4-BE49-F238E27FC236}">
+                <a16:creationId xmlns:a16="http://schemas.microsoft.com/office/drawing/2014/main" id="{9DA8D909-D968-CC02-333B-1DBF2E3D6E00}"/>
+              </a:ext>
+            </a:extLst>
+          </p:cNvPr>
+          <p:cNvPicPr>
+            <a:picLocks noChangeAspect="1"/>
+          </p:cNvPicPr>
+          <p:nvPr/>
+        </p:nvPicPr>
+        <p:blipFill>
+          <a:blip r:embed="rId2"/>
+          <a:stretch>
+            <a:fillRect/>
+          </a:stretch>
+        </p:blipFill>
+        <p:spPr>
+          <a:xfrm>
+            <a:off x="1790729" y="2352046"/>
+            <a:ext cx="9002916" cy="3529714"/>
+          </a:xfrm>
+          <a:prstGeom prst="rect">
+            <a:avLst/>
+          </a:prstGeom>
+        </p:spPr>
+      </p:pic>
+    </p:spTree>
+    <p:extLst>
+      <p:ext uri="{BB962C8B-B14F-4D97-AF65-F5344CB8AC3E}">
+        <p14:creationId xmlns:p14="http://schemas.microsoft.com/office/powerpoint/2010/main" val="175726401"/>
+      </p:ext>
+    </p:extLst>
+  </p:cSld>
+  <p:clrMapOvr>
+    <a:masterClrMapping/>
+  </p:clrMapOvr>
+</p:sld>
+</file>
+
+<file path=ppt/slides/slide12.xml><?xml version="1.0" encoding="utf-8"?>
 <p:sld xmlns:a="http://schemas.openxmlformats.org/drawingml/2006/main" xmlns:r="http://schemas.openxmlformats.org/officeDocument/2006/relationships" xmlns:p="http://schemas.openxmlformats.org/presentationml/2006/main">
   <p:cSld>
     <p:spTree>
@@ -6603,28 +6819,409 @@
           </a:p>
         </p:txBody>
       </p:sp>
-      <p:sp>
-        <p:nvSpPr>
-          <p:cNvPr id="4" name="Content Placeholder 3">
+      <p:pic>
+        <p:nvPicPr>
+          <p:cNvPr id="5" name="Picture 4">
             <a:extLst>
               <a:ext uri="{FF2B5EF4-FFF2-40B4-BE49-F238E27FC236}">
-                <a16:creationId xmlns:a16="http://schemas.microsoft.com/office/drawing/2014/main" id="{FDE522D7-72EE-563C-E025-9DB558A53C61}"/>
+                <a16:creationId xmlns:a16="http://schemas.microsoft.com/office/drawing/2014/main" id="{2C288B88-3180-7C10-8F01-3A105CA1FDAB}"/>
               </a:ext>
             </a:extLst>
           </p:cNvPr>
-          <p:cNvSpPr>
-            <a:spLocks noGrp="1"/>
-          </p:cNvSpPr>
+          <p:cNvPicPr>
+            <a:picLocks noChangeAspect="1"/>
+          </p:cNvPicPr>
+          <p:nvPr/>
+        </p:nvPicPr>
+        <p:blipFill>
+          <a:blip r:embed="rId12"/>
+          <a:stretch>
+            <a:fillRect/>
+          </a:stretch>
+        </p:blipFill>
+        <p:spPr>
+          <a:xfrm>
+            <a:off x="792111" y="2194560"/>
+            <a:ext cx="5543476" cy="3363759"/>
+          </a:xfrm>
+          <a:prstGeom prst="rect">
+            <a:avLst/>
+          </a:prstGeom>
+        </p:spPr>
+      </p:pic>
+      <p:pic>
+        <p:nvPicPr>
+          <p:cNvPr id="6" name="clean_signal">
+            <a:hlinkClick r:id="" action="ppaction://media"/>
+            <a:extLst>
+              <a:ext uri="{FF2B5EF4-FFF2-40B4-BE49-F238E27FC236}">
+                <a16:creationId xmlns:a16="http://schemas.microsoft.com/office/drawing/2014/main" id="{17013449-72F7-0CF4-272D-9F3EA80E5862}"/>
+              </a:ext>
+            </a:extLst>
+          </p:cNvPr>
+          <p:cNvPicPr>
+            <a:picLocks noGrp="1" noChangeAspect="1"/>
+          </p:cNvPicPr>
           <p:nvPr>
             <p:ph idx="1"/>
-          </p:nvPr>
-        </p:nvSpPr>
-        <p:spPr/>
-        <p:txBody>
-          <a:bodyPr/>
+            <a:audioFile r:link="rId2"/>
+            <p:extLst>
+              <p:ext uri="{DAA4B4D4-6D71-4841-9C94-3DE7FCFB9230}">
+                <p14:media xmlns:p14="http://schemas.microsoft.com/office/powerpoint/2010/main" r:embed="rId1"/>
+              </p:ext>
+            </p:extLst>
+          </p:nvPr>
+        </p:nvPicPr>
+        <p:blipFill>
+          <a:blip r:embed="rId13"/>
+          <a:stretch>
+            <a:fillRect/>
+          </a:stretch>
+        </p:blipFill>
+        <p:spPr>
+          <a:xfrm>
+            <a:off x="10373472" y="2731213"/>
+            <a:ext cx="609601" cy="609601"/>
+          </a:xfrm>
+          <a:prstGeom prst="rect">
+            <a:avLst/>
+          </a:prstGeom>
+        </p:spPr>
+      </p:pic>
+      <p:pic>
+        <p:nvPicPr>
+          <p:cNvPr id="7" name="moving_noise">
+            <a:hlinkClick r:id="" action="ppaction://media"/>
+            <a:extLst>
+              <a:ext uri="{FF2B5EF4-FFF2-40B4-BE49-F238E27FC236}">
+                <a16:creationId xmlns:a16="http://schemas.microsoft.com/office/drawing/2014/main" id="{F09BFAC7-4BBB-16A4-BB27-DC1CE07A2628}"/>
+              </a:ext>
+            </a:extLst>
+          </p:cNvPr>
+          <p:cNvPicPr>
+            <a:picLocks noChangeAspect="1"/>
+          </p:cNvPicPr>
+          <p:nvPr>
+            <a:audioFile r:link="rId4"/>
+            <p:extLst>
+              <p:ext uri="{DAA4B4D4-6D71-4841-9C94-3DE7FCFB9230}">
+                <p14:media xmlns:p14="http://schemas.microsoft.com/office/powerpoint/2010/main" r:embed="rId3"/>
+              </p:ext>
+            </p:extLst>
+          </p:nvPr>
+        </p:nvPicPr>
+        <p:blipFill>
+          <a:blip r:embed="rId13"/>
+          <a:stretch>
+            <a:fillRect/>
+          </a:stretch>
+        </p:blipFill>
+        <p:spPr>
+          <a:xfrm>
+            <a:off x="10373473" y="4075096"/>
+            <a:ext cx="609600" cy="609600"/>
+          </a:xfrm>
+          <a:prstGeom prst="rect">
+            <a:avLst/>
+          </a:prstGeom>
+        </p:spPr>
+      </p:pic>
+      <p:sp>
+        <p:nvSpPr>
+          <p:cNvPr id="8" name="TextBox 7">
+            <a:extLst>
+              <a:ext uri="{FF2B5EF4-FFF2-40B4-BE49-F238E27FC236}">
+                <a16:creationId xmlns:a16="http://schemas.microsoft.com/office/drawing/2014/main" id="{E1D9B044-3415-D6AE-6A90-BB4AC59FE01A}"/>
+              </a:ext>
+            </a:extLst>
+          </p:cNvPr>
+          <p:cNvSpPr txBox="1"/>
+          <p:nvPr/>
+        </p:nvSpPr>
+        <p:spPr>
+          <a:xfrm>
+            <a:off x="9863075" y="2209641"/>
+            <a:ext cx="1322173" cy="369332"/>
+          </a:xfrm>
+          <a:prstGeom prst="rect">
+            <a:avLst/>
+          </a:prstGeom>
+          <a:noFill/>
+        </p:spPr>
+        <p:txBody>
+          <a:bodyPr wrap="square" rtlCol="0">
+            <a:spAutoFit/>
+          </a:bodyPr>
           <a:lstStyle/>
           <a:p>
-            <a:endParaRPr lang="en-IL"/>
+            <a:pPr marL="0" algn="r" defTabSz="457200" rtl="1" eaLnBrk="1" latinLnBrk="0" hangingPunct="1"/>
+            <a:r>
+              <a:rPr lang="he-IL" dirty="0"/>
+              <a:t>אות המקור</a:t>
+            </a:r>
+            <a:endParaRPr lang="en-IL" dirty="0"/>
+          </a:p>
+        </p:txBody>
+      </p:sp>
+      <p:sp>
+        <p:nvSpPr>
+          <p:cNvPr id="9" name="TextBox 8">
+            <a:extLst>
+              <a:ext uri="{FF2B5EF4-FFF2-40B4-BE49-F238E27FC236}">
+                <a16:creationId xmlns:a16="http://schemas.microsoft.com/office/drawing/2014/main" id="{F464B26D-32D4-5605-C93A-5B0ADC4C6ECD}"/>
+              </a:ext>
+            </a:extLst>
+          </p:cNvPr>
+          <p:cNvSpPr txBox="1"/>
+          <p:nvPr/>
+        </p:nvSpPr>
+        <p:spPr>
+          <a:xfrm>
+            <a:off x="9863075" y="3589535"/>
+            <a:ext cx="1322173" cy="369332"/>
+          </a:xfrm>
+          <a:prstGeom prst="rect">
+            <a:avLst/>
+          </a:prstGeom>
+          <a:noFill/>
+        </p:spPr>
+        <p:txBody>
+          <a:bodyPr wrap="square" rtlCol="0">
+            <a:spAutoFit/>
+          </a:bodyPr>
+          <a:lstStyle/>
+          <a:p>
+            <a:pPr marL="0" algn="r" defTabSz="457200" rtl="1" eaLnBrk="1" latinLnBrk="0" hangingPunct="1"/>
+            <a:r>
+              <a:rPr lang="he-IL" dirty="0"/>
+              <a:t>אות הרעש</a:t>
+            </a:r>
+            <a:endParaRPr lang="en-IL" dirty="0"/>
+          </a:p>
+        </p:txBody>
+      </p:sp>
+      <p:sp>
+        <p:nvSpPr>
+          <p:cNvPr id="10" name="TextBox 9">
+            <a:extLst>
+              <a:ext uri="{FF2B5EF4-FFF2-40B4-BE49-F238E27FC236}">
+                <a16:creationId xmlns:a16="http://schemas.microsoft.com/office/drawing/2014/main" id="{4976496A-6880-739E-7785-C035B0E2BE9A}"/>
+              </a:ext>
+            </a:extLst>
+          </p:cNvPr>
+          <p:cNvSpPr txBox="1"/>
+          <p:nvPr/>
+        </p:nvSpPr>
+        <p:spPr>
+          <a:xfrm>
+            <a:off x="7695344" y="2206378"/>
+            <a:ext cx="1620008" cy="646331"/>
+          </a:xfrm>
+          <a:prstGeom prst="rect">
+            <a:avLst/>
+          </a:prstGeom>
+          <a:noFill/>
+        </p:spPr>
+        <p:txBody>
+          <a:bodyPr wrap="square" rtlCol="0">
+            <a:spAutoFit/>
+          </a:bodyPr>
+          <a:lstStyle/>
+          <a:p>
+            <a:pPr marL="0" algn="r" defTabSz="457200" rtl="1" eaLnBrk="1" latinLnBrk="0" hangingPunct="1"/>
+            <a:r>
+              <a:rPr lang="he-IL" dirty="0"/>
+              <a:t>המקור עם הרעש</a:t>
+            </a:r>
+            <a:endParaRPr lang="en-IL" dirty="0"/>
+          </a:p>
+        </p:txBody>
+      </p:sp>
+      <p:pic>
+        <p:nvPicPr>
+          <p:cNvPr id="11" name="noisy_signal">
+            <a:hlinkClick r:id="" action="ppaction://media"/>
+            <a:extLst>
+              <a:ext uri="{FF2B5EF4-FFF2-40B4-BE49-F238E27FC236}">
+                <a16:creationId xmlns:a16="http://schemas.microsoft.com/office/drawing/2014/main" id="{C9FA86B1-2D27-E519-0066-07F62C6D1F43}"/>
+              </a:ext>
+            </a:extLst>
+          </p:cNvPr>
+          <p:cNvPicPr>
+            <a:picLocks noChangeAspect="1"/>
+          </p:cNvPicPr>
+          <p:nvPr>
+            <a:audioFile r:link="rId6"/>
+            <p:extLst>
+              <p:ext uri="{DAA4B4D4-6D71-4841-9C94-3DE7FCFB9230}">
+                <p14:media xmlns:p14="http://schemas.microsoft.com/office/powerpoint/2010/main" r:embed="rId5"/>
+              </p:ext>
+            </p:extLst>
+          </p:nvPr>
+        </p:nvPicPr>
+        <p:blipFill>
+          <a:blip r:embed="rId13"/>
+          <a:stretch>
+            <a:fillRect/>
+          </a:stretch>
+        </p:blipFill>
+        <p:spPr>
+          <a:xfrm>
+            <a:off x="8505348" y="2979935"/>
+            <a:ext cx="609600" cy="609600"/>
+          </a:xfrm>
+          <a:prstGeom prst="rect">
+            <a:avLst/>
+          </a:prstGeom>
+        </p:spPr>
+      </p:pic>
+      <p:pic>
+        <p:nvPicPr>
+          <p:cNvPr id="12" name="prop_relax_online_out_signal_0">
+            <a:hlinkClick r:id="" action="ppaction://media"/>
+            <a:extLst>
+              <a:ext uri="{FF2B5EF4-FFF2-40B4-BE49-F238E27FC236}">
+                <a16:creationId xmlns:a16="http://schemas.microsoft.com/office/drawing/2014/main" id="{4799AE6A-8765-EA9E-AE6F-FC94D64C1CAE}"/>
+              </a:ext>
+            </a:extLst>
+          </p:cNvPr>
+          <p:cNvPicPr>
+            <a:picLocks noChangeAspect="1"/>
+          </p:cNvPicPr>
+          <p:nvPr>
+            <a:audioFile r:link="rId8"/>
+            <p:extLst>
+              <p:ext uri="{DAA4B4D4-6D71-4841-9C94-3DE7FCFB9230}">
+                <p14:media xmlns:p14="http://schemas.microsoft.com/office/powerpoint/2010/main" r:embed="rId7"/>
+              </p:ext>
+            </p:extLst>
+          </p:nvPr>
+        </p:nvPicPr>
+        <p:blipFill>
+          <a:blip r:embed="rId13"/>
+          <a:stretch>
+            <a:fillRect/>
+          </a:stretch>
+        </p:blipFill>
+        <p:spPr>
+          <a:xfrm>
+            <a:off x="8505348" y="4253038"/>
+            <a:ext cx="609600" cy="609600"/>
+          </a:xfrm>
+          <a:prstGeom prst="rect">
+            <a:avLst/>
+          </a:prstGeom>
+        </p:spPr>
+      </p:pic>
+      <p:pic>
+        <p:nvPicPr>
+          <p:cNvPr id="13" name="prop_relax_out_signal_0">
+            <a:hlinkClick r:id="" action="ppaction://media"/>
+            <a:extLst>
+              <a:ext uri="{FF2B5EF4-FFF2-40B4-BE49-F238E27FC236}">
+                <a16:creationId xmlns:a16="http://schemas.microsoft.com/office/drawing/2014/main" id="{51E4AE1B-EE8D-8D58-FEB1-885FEEDEB8AE}"/>
+              </a:ext>
+            </a:extLst>
+          </p:cNvPr>
+          <p:cNvPicPr>
+            <a:picLocks noChangeAspect="1"/>
+          </p:cNvPicPr>
+          <p:nvPr>
+            <a:audioFile r:link="rId10"/>
+            <p:extLst>
+              <p:ext uri="{DAA4B4D4-6D71-4841-9C94-3DE7FCFB9230}">
+                <p14:media xmlns:p14="http://schemas.microsoft.com/office/powerpoint/2010/main" r:embed="rId9"/>
+              </p:ext>
+            </p:extLst>
+          </p:nvPr>
+        </p:nvPicPr>
+        <p:blipFill>
+          <a:blip r:embed="rId13"/>
+          <a:stretch>
+            <a:fillRect/>
+          </a:stretch>
+        </p:blipFill>
+        <p:spPr>
+          <a:xfrm>
+            <a:off x="8505348" y="5484027"/>
+            <a:ext cx="609600" cy="609600"/>
+          </a:xfrm>
+          <a:prstGeom prst="rect">
+            <a:avLst/>
+          </a:prstGeom>
+        </p:spPr>
+      </p:pic>
+      <p:sp>
+        <p:nvSpPr>
+          <p:cNvPr id="14" name="TextBox 13">
+            <a:extLst>
+              <a:ext uri="{FF2B5EF4-FFF2-40B4-BE49-F238E27FC236}">
+                <a16:creationId xmlns:a16="http://schemas.microsoft.com/office/drawing/2014/main" id="{37BA44FE-6424-366E-62A2-8EED47228A9A}"/>
+              </a:ext>
+            </a:extLst>
+          </p:cNvPr>
+          <p:cNvSpPr txBox="1"/>
+          <p:nvPr/>
+        </p:nvSpPr>
+        <p:spPr>
+          <a:xfrm>
+            <a:off x="7695344" y="3745829"/>
+            <a:ext cx="1620008" cy="369332"/>
+          </a:xfrm>
+          <a:prstGeom prst="rect">
+            <a:avLst/>
+          </a:prstGeom>
+          <a:noFill/>
+        </p:spPr>
+        <p:txBody>
+          <a:bodyPr wrap="square" rtlCol="0">
+            <a:spAutoFit/>
+          </a:bodyPr>
+          <a:lstStyle/>
+          <a:p>
+            <a:pPr marL="0" algn="r" defTabSz="457200" rtl="1" eaLnBrk="1" latinLnBrk="0" hangingPunct="1"/>
+            <a:r>
+              <a:rPr lang="he-IL" dirty="0"/>
+              <a:t>זמן אמת</a:t>
+            </a:r>
+            <a:endParaRPr lang="en-IL" dirty="0"/>
+          </a:p>
+        </p:txBody>
+      </p:sp>
+      <p:sp>
+        <p:nvSpPr>
+          <p:cNvPr id="15" name="TextBox 14">
+            <a:extLst>
+              <a:ext uri="{FF2B5EF4-FFF2-40B4-BE49-F238E27FC236}">
+                <a16:creationId xmlns:a16="http://schemas.microsoft.com/office/drawing/2014/main" id="{A7187212-9DED-D462-5E74-ECDAFE30123B}"/>
+              </a:ext>
+            </a:extLst>
+          </p:cNvPr>
+          <p:cNvSpPr txBox="1"/>
+          <p:nvPr/>
+        </p:nvSpPr>
+        <p:spPr>
+          <a:xfrm>
+            <a:off x="7695344" y="5114695"/>
+            <a:ext cx="1620008" cy="369332"/>
+          </a:xfrm>
+          <a:prstGeom prst="rect">
+            <a:avLst/>
+          </a:prstGeom>
+          <a:noFill/>
+        </p:spPr>
+        <p:txBody>
+          <a:bodyPr wrap="square" rtlCol="0">
+            <a:spAutoFit/>
+          </a:bodyPr>
+          <a:lstStyle/>
+          <a:p>
+            <a:pPr marL="0" algn="r" defTabSz="457200" rtl="1" eaLnBrk="1" latinLnBrk="0" hangingPunct="1"/>
+            <a:r>
+              <a:rPr lang="he-IL" dirty="0"/>
+              <a:t>בדיעבד</a:t>
+            </a:r>
+            <a:endParaRPr lang="en-IL" dirty="0"/>
           </a:p>
         </p:txBody>
       </p:sp>
@@ -6638,107 +7235,306 @@
   <p:clrMapOvr>
     <a:masterClrMapping/>
   </p:clrMapOvr>
-</p:sld>
-</file>
-
-<file path=ppt/slides/slide12.xml><?xml version="1.0" encoding="utf-8"?>
-<p:sld xmlns:a="http://schemas.openxmlformats.org/drawingml/2006/main" xmlns:r="http://schemas.openxmlformats.org/officeDocument/2006/relationships" xmlns:p="http://schemas.openxmlformats.org/presentationml/2006/main">
-  <p:cSld>
-    <p:spTree>
-      <p:nvGrpSpPr>
-        <p:cNvPr id="1" name=""/>
-        <p:cNvGrpSpPr/>
-        <p:nvPr/>
-      </p:nvGrpSpPr>
-      <p:grpSpPr>
-        <a:xfrm>
-          <a:off x="0" y="0"/>
-          <a:ext cx="0" cy="0"/>
-          <a:chOff x="0" y="0"/>
-          <a:chExt cx="0" cy="0"/>
-        </a:xfrm>
-      </p:grpSpPr>
-      <p:sp>
-        <p:nvSpPr>
-          <p:cNvPr id="2" name="Title 1">
-            <a:extLst>
-              <a:ext uri="{FF2B5EF4-FFF2-40B4-BE49-F238E27FC236}">
-                <a16:creationId xmlns:a16="http://schemas.microsoft.com/office/drawing/2014/main" id="{8603BD4E-1B90-07B0-3994-AB562D4EAF9B}"/>
-              </a:ext>
-            </a:extLst>
-          </p:cNvPr>
-          <p:cNvSpPr>
-            <a:spLocks noGrp="1"/>
-          </p:cNvSpPr>
-          <p:nvPr>
-            <p:ph type="title"/>
-          </p:nvPr>
-        </p:nvSpPr>
-        <p:spPr/>
-        <p:txBody>
-          <a:bodyPr>
-            <a:normAutofit/>
-          </a:bodyPr>
-          <a:lstStyle/>
-          <a:p>
-            <a:pPr algn="r" rtl="1"/>
-            <a:r>
-              <a:rPr lang="he-IL" dirty="0">
-                <a:cs typeface="+mn-cs"/>
-              </a:rPr>
-              <a:t>החידוש והתרומה של המאמר ביחס לקיים</a:t>
-            </a:r>
-            <a:endParaRPr lang="en-IL" dirty="0">
-              <a:cs typeface="+mn-cs"/>
-            </a:endParaRPr>
-          </a:p>
-        </p:txBody>
-      </p:sp>
-      <p:sp>
-        <p:nvSpPr>
-          <p:cNvPr id="3" name="Content Placeholder 2">
-            <a:extLst>
-              <a:ext uri="{FF2B5EF4-FFF2-40B4-BE49-F238E27FC236}">
-                <a16:creationId xmlns:a16="http://schemas.microsoft.com/office/drawing/2014/main" id="{7D95B9DE-E819-6172-C676-FF5D38DCED48}"/>
-              </a:ext>
-            </a:extLst>
-          </p:cNvPr>
-          <p:cNvSpPr>
-            <a:spLocks noGrp="1"/>
-          </p:cNvSpPr>
-          <p:nvPr>
-            <p:ph idx="1"/>
-          </p:nvPr>
-        </p:nvSpPr>
-        <p:spPr/>
-        <p:txBody>
-          <a:bodyPr/>
-          <a:lstStyle/>
-          <a:p>
-            <a:pPr marL="228600" indent="-228600" algn="r" defTabSz="914400" rtl="1" eaLnBrk="1" latinLnBrk="0" hangingPunct="1">
-              <a:lnSpc>
-                <a:spcPct val="90000"/>
-              </a:lnSpc>
-              <a:spcBef>
-                <a:spcPts val="1000"/>
-              </a:spcBef>
-              <a:buFont typeface="Arial" panose="020B0604020202020204" pitchFamily="34" charset="0"/>
-              <a:buChar char="•"/>
-            </a:pPr>
-            <a:endParaRPr lang="en-IL" dirty="0"/>
-          </a:p>
-        </p:txBody>
-      </p:sp>
-    </p:spTree>
-    <p:extLst>
-      <p:ext uri="{BB962C8B-B14F-4D97-AF65-F5344CB8AC3E}">
-        <p14:creationId xmlns:p14="http://schemas.microsoft.com/office/powerpoint/2010/main" val="179345606"/>
-      </p:ext>
-    </p:extLst>
-  </p:cSld>
-  <p:clrMapOvr>
-    <a:masterClrMapping/>
-  </p:clrMapOvr>
+  <p:timing>
+    <p:tnLst>
+      <p:par>
+        <p:cTn id="1" dur="indefinite" restart="never" nodeType="tmRoot">
+          <p:childTnLst>
+            <p:seq concurrent="1" nextAc="seek">
+              <p:cTn id="2" dur="indefinite" nodeType="mainSeq">
+                <p:childTnLst>
+                  <p:par>
+                    <p:cTn id="3" fill="hold">
+                      <p:stCondLst>
+                        <p:cond delay="indefinite"/>
+                      </p:stCondLst>
+                      <p:childTnLst>
+                        <p:par>
+                          <p:cTn id="4" fill="hold">
+                            <p:stCondLst>
+                              <p:cond delay="0"/>
+                            </p:stCondLst>
+                            <p:childTnLst>
+                              <p:par>
+                                <p:cTn id="5" presetID="1" presetClass="mediacall" presetSubtype="0" fill="hold" nodeType="clickEffect">
+                                  <p:stCondLst>
+                                    <p:cond delay="0"/>
+                                  </p:stCondLst>
+                                  <p:childTnLst>
+                                    <p:cmd type="call" cmd="playFrom(0.0)">
+                                      <p:cBhvr>
+                                        <p:cTn id="6" dur="10000" fill="hold"/>
+                                        <p:tgtEl>
+                                          <p:spTgt spid="6"/>
+                                        </p:tgtEl>
+                                      </p:cBhvr>
+                                    </p:cmd>
+                                  </p:childTnLst>
+                                </p:cTn>
+                              </p:par>
+                            </p:childTnLst>
+                          </p:cTn>
+                        </p:par>
+                      </p:childTnLst>
+                    </p:cTn>
+                  </p:par>
+                  <p:par>
+                    <p:cTn id="7" fill="hold">
+                      <p:stCondLst>
+                        <p:cond delay="indefinite"/>
+                      </p:stCondLst>
+                      <p:childTnLst>
+                        <p:par>
+                          <p:cTn id="8" fill="hold">
+                            <p:stCondLst>
+                              <p:cond delay="0"/>
+                            </p:stCondLst>
+                            <p:childTnLst>
+                              <p:par>
+                                <p:cTn id="9" presetID="1" presetClass="mediacall" presetSubtype="0" fill="hold" nodeType="clickEffect">
+                                  <p:stCondLst>
+                                    <p:cond delay="0"/>
+                                  </p:stCondLst>
+                                  <p:childTnLst>
+                                    <p:cmd type="call" cmd="playFrom(0.0)">
+                                      <p:cBhvr>
+                                        <p:cTn id="10" dur="10000" fill="hold"/>
+                                        <p:tgtEl>
+                                          <p:spTgt spid="7"/>
+                                        </p:tgtEl>
+                                      </p:cBhvr>
+                                    </p:cmd>
+                                  </p:childTnLst>
+                                </p:cTn>
+                              </p:par>
+                            </p:childTnLst>
+                          </p:cTn>
+                        </p:par>
+                      </p:childTnLst>
+                    </p:cTn>
+                  </p:par>
+                  <p:par>
+                    <p:cTn id="11" fill="hold">
+                      <p:stCondLst>
+                        <p:cond delay="indefinite"/>
+                      </p:stCondLst>
+                      <p:childTnLst>
+                        <p:par>
+                          <p:cTn id="12" fill="hold">
+                            <p:stCondLst>
+                              <p:cond delay="0"/>
+                            </p:stCondLst>
+                            <p:childTnLst>
+                              <p:par>
+                                <p:cTn id="13" presetID="1" presetClass="mediacall" presetSubtype="0" fill="hold" nodeType="clickEffect">
+                                  <p:stCondLst>
+                                    <p:cond delay="0"/>
+                                  </p:stCondLst>
+                                  <p:childTnLst>
+                                    <p:cmd type="call" cmd="playFrom(0.0)">
+                                      <p:cBhvr>
+                                        <p:cTn id="14" dur="10000" fill="hold"/>
+                                        <p:tgtEl>
+                                          <p:spTgt spid="11"/>
+                                        </p:tgtEl>
+                                      </p:cBhvr>
+                                    </p:cmd>
+                                  </p:childTnLst>
+                                </p:cTn>
+                              </p:par>
+                            </p:childTnLst>
+                          </p:cTn>
+                        </p:par>
+                      </p:childTnLst>
+                    </p:cTn>
+                  </p:par>
+                  <p:par>
+                    <p:cTn id="15" fill="hold">
+                      <p:stCondLst>
+                        <p:cond delay="indefinite"/>
+                      </p:stCondLst>
+                      <p:childTnLst>
+                        <p:par>
+                          <p:cTn id="16" fill="hold">
+                            <p:stCondLst>
+                              <p:cond delay="0"/>
+                            </p:stCondLst>
+                            <p:childTnLst>
+                              <p:par>
+                                <p:cTn id="17" presetID="1" presetClass="mediacall" presetSubtype="0" fill="hold" nodeType="clickEffect">
+                                  <p:stCondLst>
+                                    <p:cond delay="0"/>
+                                  </p:stCondLst>
+                                  <p:childTnLst>
+                                    <p:cmd type="call" cmd="playFrom(0.0)">
+                                      <p:cBhvr>
+                                        <p:cTn id="18" dur="9984" fill="hold"/>
+                                        <p:tgtEl>
+                                          <p:spTgt spid="12"/>
+                                        </p:tgtEl>
+                                      </p:cBhvr>
+                                    </p:cmd>
+                                  </p:childTnLst>
+                                </p:cTn>
+                              </p:par>
+                            </p:childTnLst>
+                          </p:cTn>
+                        </p:par>
+                      </p:childTnLst>
+                    </p:cTn>
+                  </p:par>
+                  <p:par>
+                    <p:cTn id="19" fill="hold">
+                      <p:stCondLst>
+                        <p:cond delay="indefinite"/>
+                      </p:stCondLst>
+                      <p:childTnLst>
+                        <p:par>
+                          <p:cTn id="20" fill="hold">
+                            <p:stCondLst>
+                              <p:cond delay="0"/>
+                            </p:stCondLst>
+                            <p:childTnLst>
+                              <p:par>
+                                <p:cTn id="21" presetID="1" presetClass="mediacall" presetSubtype="0" fill="hold" nodeType="clickEffect">
+                                  <p:stCondLst>
+                                    <p:cond delay="0"/>
+                                  </p:stCondLst>
+                                  <p:childTnLst>
+                                    <p:cmd type="call" cmd="playFrom(0.0)">
+                                      <p:cBhvr>
+                                        <p:cTn id="22" dur="10000" fill="hold"/>
+                                        <p:tgtEl>
+                                          <p:spTgt spid="13"/>
+                                        </p:tgtEl>
+                                      </p:cBhvr>
+                                    </p:cmd>
+                                  </p:childTnLst>
+                                </p:cTn>
+                              </p:par>
+                            </p:childTnLst>
+                          </p:cTn>
+                        </p:par>
+                      </p:childTnLst>
+                    </p:cTn>
+                  </p:par>
+                </p:childTnLst>
+              </p:cTn>
+              <p:prevCondLst>
+                <p:cond evt="onPrev" delay="0">
+                  <p:tgtEl>
+                    <p:sldTgt/>
+                  </p:tgtEl>
+                </p:cond>
+              </p:prevCondLst>
+              <p:nextCondLst>
+                <p:cond evt="onNext" delay="0">
+                  <p:tgtEl>
+                    <p:sldTgt/>
+                  </p:tgtEl>
+                </p:cond>
+              </p:nextCondLst>
+            </p:seq>
+            <p:audio>
+              <p:cMediaNode vol="80000">
+                <p:cTn id="23" fill="hold" display="0">
+                  <p:stCondLst>
+                    <p:cond delay="indefinite"/>
+                  </p:stCondLst>
+                  <p:endCondLst>
+                    <p:cond evt="onStopAudio" delay="0">
+                      <p:tgtEl>
+                        <p:sldTgt/>
+                      </p:tgtEl>
+                    </p:cond>
+                  </p:endCondLst>
+                </p:cTn>
+                <p:tgtEl>
+                  <p:spTgt spid="6"/>
+                </p:tgtEl>
+              </p:cMediaNode>
+            </p:audio>
+            <p:audio>
+              <p:cMediaNode vol="80000">
+                <p:cTn id="24" fill="hold" display="0">
+                  <p:stCondLst>
+                    <p:cond delay="indefinite"/>
+                  </p:stCondLst>
+                  <p:endCondLst>
+                    <p:cond evt="onStopAudio" delay="0">
+                      <p:tgtEl>
+                        <p:sldTgt/>
+                      </p:tgtEl>
+                    </p:cond>
+                  </p:endCondLst>
+                </p:cTn>
+                <p:tgtEl>
+                  <p:spTgt spid="7"/>
+                </p:tgtEl>
+              </p:cMediaNode>
+            </p:audio>
+            <p:audio>
+              <p:cMediaNode vol="80000">
+                <p:cTn id="25" fill="hold" display="0">
+                  <p:stCondLst>
+                    <p:cond delay="indefinite"/>
+                  </p:stCondLst>
+                  <p:endCondLst>
+                    <p:cond evt="onStopAudio" delay="0">
+                      <p:tgtEl>
+                        <p:sldTgt/>
+                      </p:tgtEl>
+                    </p:cond>
+                  </p:endCondLst>
+                </p:cTn>
+                <p:tgtEl>
+                  <p:spTgt spid="11"/>
+                </p:tgtEl>
+              </p:cMediaNode>
+            </p:audio>
+            <p:audio>
+              <p:cMediaNode vol="80000">
+                <p:cTn id="26" fill="hold" display="0">
+                  <p:stCondLst>
+                    <p:cond delay="indefinite"/>
+                  </p:stCondLst>
+                  <p:endCondLst>
+                    <p:cond evt="onStopAudio" delay="0">
+                      <p:tgtEl>
+                        <p:sldTgt/>
+                      </p:tgtEl>
+                    </p:cond>
+                  </p:endCondLst>
+                </p:cTn>
+                <p:tgtEl>
+                  <p:spTgt spid="12"/>
+                </p:tgtEl>
+              </p:cMediaNode>
+            </p:audio>
+            <p:audio>
+              <p:cMediaNode vol="80000">
+                <p:cTn id="27" fill="hold" display="0">
+                  <p:stCondLst>
+                    <p:cond delay="indefinite"/>
+                  </p:stCondLst>
+                  <p:endCondLst>
+                    <p:cond evt="onStopAudio" delay="0">
+                      <p:tgtEl>
+                        <p:sldTgt/>
+                      </p:tgtEl>
+                    </p:cond>
+                  </p:endCondLst>
+                </p:cTn>
+                <p:tgtEl>
+                  <p:spTgt spid="13"/>
+                </p:tgtEl>
+              </p:cMediaNode>
+            </p:audio>
+          </p:childTnLst>
+        </p:cTn>
+      </p:par>
+    </p:tnLst>
+  </p:timing>
 </p:sld>
 </file>
 
@@ -6764,6 +7560,131 @@
           <p:cNvPr id="2" name="Title 1">
             <a:extLst>
               <a:ext uri="{FF2B5EF4-FFF2-40B4-BE49-F238E27FC236}">
+                <a16:creationId xmlns:a16="http://schemas.microsoft.com/office/drawing/2014/main" id="{8603BD4E-1B90-07B0-3994-AB562D4EAF9B}"/>
+              </a:ext>
+            </a:extLst>
+          </p:cNvPr>
+          <p:cNvSpPr>
+            <a:spLocks noGrp="1"/>
+          </p:cNvSpPr>
+          <p:nvPr>
+            <p:ph type="title"/>
+          </p:nvPr>
+        </p:nvSpPr>
+        <p:spPr/>
+        <p:txBody>
+          <a:bodyPr>
+            <a:normAutofit/>
+          </a:bodyPr>
+          <a:lstStyle/>
+          <a:p>
+            <a:pPr algn="r" rtl="1"/>
+            <a:r>
+              <a:rPr lang="he-IL" dirty="0">
+                <a:cs typeface="+mn-cs"/>
+              </a:rPr>
+              <a:t>החידוש והתרומה של המאמר ביחס לקיים</a:t>
+            </a:r>
+            <a:endParaRPr lang="en-IL" dirty="0">
+              <a:cs typeface="+mn-cs"/>
+            </a:endParaRPr>
+          </a:p>
+        </p:txBody>
+      </p:sp>
+      <p:pic>
+        <p:nvPicPr>
+          <p:cNvPr id="5" name="Content Placeholder 4">
+            <a:extLst>
+              <a:ext uri="{FF2B5EF4-FFF2-40B4-BE49-F238E27FC236}">
+                <a16:creationId xmlns:a16="http://schemas.microsoft.com/office/drawing/2014/main" id="{057E6C3E-01F6-2CDF-CD4F-264CCA52D342}"/>
+              </a:ext>
+            </a:extLst>
+          </p:cNvPr>
+          <p:cNvPicPr>
+            <a:picLocks noGrp="1" noChangeAspect="1"/>
+          </p:cNvPicPr>
+          <p:nvPr>
+            <p:ph idx="1"/>
+          </p:nvPr>
+        </p:nvPicPr>
+        <p:blipFill>
+          <a:blip r:embed="rId2"/>
+          <a:stretch>
+            <a:fillRect/>
+          </a:stretch>
+        </p:blipFill>
+        <p:spPr>
+          <a:xfrm>
+            <a:off x="599933" y="1937071"/>
+            <a:ext cx="4889283" cy="4024313"/>
+          </a:xfrm>
+        </p:spPr>
+      </p:pic>
+      <p:pic>
+        <p:nvPicPr>
+          <p:cNvPr id="7" name="Picture 6">
+            <a:extLst>
+              <a:ext uri="{FF2B5EF4-FFF2-40B4-BE49-F238E27FC236}">
+                <a16:creationId xmlns:a16="http://schemas.microsoft.com/office/drawing/2014/main" id="{D40899F9-7815-3CE3-E894-245215CDAC4F}"/>
+              </a:ext>
+            </a:extLst>
+          </p:cNvPr>
+          <p:cNvPicPr>
+            <a:picLocks noChangeAspect="1"/>
+          </p:cNvPicPr>
+          <p:nvPr/>
+        </p:nvPicPr>
+        <p:blipFill>
+          <a:blip r:embed="rId3"/>
+          <a:stretch>
+            <a:fillRect/>
+          </a:stretch>
+        </p:blipFill>
+        <p:spPr>
+          <a:xfrm>
+            <a:off x="6096000" y="1777078"/>
+            <a:ext cx="5056836" cy="4227971"/>
+          </a:xfrm>
+          <a:prstGeom prst="rect">
+            <a:avLst/>
+          </a:prstGeom>
+        </p:spPr>
+      </p:pic>
+    </p:spTree>
+    <p:extLst>
+      <p:ext uri="{BB962C8B-B14F-4D97-AF65-F5344CB8AC3E}">
+        <p14:creationId xmlns:p14="http://schemas.microsoft.com/office/powerpoint/2010/main" val="179345606"/>
+      </p:ext>
+    </p:extLst>
+  </p:cSld>
+  <p:clrMapOvr>
+    <a:masterClrMapping/>
+  </p:clrMapOvr>
+</p:sld>
+</file>
+
+<file path=ppt/slides/slide14.xml><?xml version="1.0" encoding="utf-8"?>
+<p:sld xmlns:a="http://schemas.openxmlformats.org/drawingml/2006/main" xmlns:r="http://schemas.openxmlformats.org/officeDocument/2006/relationships" xmlns:p="http://schemas.openxmlformats.org/presentationml/2006/main">
+  <p:cSld>
+    <p:spTree>
+      <p:nvGrpSpPr>
+        <p:cNvPr id="1" name=""/>
+        <p:cNvGrpSpPr/>
+        <p:nvPr/>
+      </p:nvGrpSpPr>
+      <p:grpSpPr>
+        <a:xfrm>
+          <a:off x="0" y="0"/>
+          <a:ext cx="0" cy="0"/>
+          <a:chOff x="0" y="0"/>
+          <a:chExt cx="0" cy="0"/>
+        </a:xfrm>
+      </p:grpSpPr>
+      <p:sp>
+        <p:nvSpPr>
+          <p:cNvPr id="2" name="Title 1">
+            <a:extLst>
+              <a:ext uri="{FF2B5EF4-FFF2-40B4-BE49-F238E27FC236}">
                 <a16:creationId xmlns:a16="http://schemas.microsoft.com/office/drawing/2014/main" id="{EBD4C7C2-0A9C-115A-3786-9B69A1EE4F8F}"/>
               </a:ext>
             </a:extLst>
@@ -6886,6 +7807,36 @@
               <a:rPr lang="he-IL" dirty="0"/>
               <a:t>איכון דוברים לאתחול מקדמי המסנן</a:t>
             </a:r>
+            <a:endParaRPr lang="en-US" dirty="0"/>
+          </a:p>
+          <a:p>
+            <a:pPr marL="228600" indent="-228600" algn="r" defTabSz="914400" rtl="1" eaLnBrk="1" latinLnBrk="0" hangingPunct="1">
+              <a:lnSpc>
+                <a:spcPct val="90000"/>
+              </a:lnSpc>
+              <a:spcBef>
+                <a:spcPts val="1000"/>
+              </a:spcBef>
+              <a:buFont typeface="Arial" panose="020B0604020202020204" pitchFamily="34" charset="0"/>
+              <a:buChar char="•"/>
+            </a:pPr>
+            <a:endParaRPr lang="en-US" dirty="0"/>
+          </a:p>
+          <a:p>
+            <a:pPr marL="228600" indent="-228600" algn="r" defTabSz="914400" rtl="1" eaLnBrk="1" latinLnBrk="0" hangingPunct="1">
+              <a:lnSpc>
+                <a:spcPct val="90000"/>
+              </a:lnSpc>
+              <a:spcBef>
+                <a:spcPts val="1000"/>
+              </a:spcBef>
+              <a:buFont typeface="Arial" panose="020B0604020202020204" pitchFamily="34" charset="0"/>
+              <a:buChar char="•"/>
+            </a:pPr>
+            <a:r>
+              <a:rPr lang="he-IL" dirty="0"/>
+              <a:t>בחינת התכנסות הפתרון</a:t>
+            </a:r>
             <a:endParaRPr lang="en-IL" dirty="0"/>
           </a:p>
         </p:txBody>
@@ -6894,6 +7845,208 @@
     <p:extLst>
       <p:ext uri="{BB962C8B-B14F-4D97-AF65-F5344CB8AC3E}">
         <p14:creationId xmlns:p14="http://schemas.microsoft.com/office/powerpoint/2010/main" val="798341282"/>
+      </p:ext>
+    </p:extLst>
+  </p:cSld>
+  <p:clrMapOvr>
+    <a:masterClrMapping/>
+  </p:clrMapOvr>
+</p:sld>
+</file>
+
+<file path=ppt/slides/slide15.xml><?xml version="1.0" encoding="utf-8"?>
+<p:sld xmlns:a="http://schemas.openxmlformats.org/drawingml/2006/main" xmlns:r="http://schemas.openxmlformats.org/officeDocument/2006/relationships" xmlns:p="http://schemas.openxmlformats.org/presentationml/2006/main">
+  <p:cSld>
+    <p:spTree>
+      <p:nvGrpSpPr>
+        <p:cNvPr id="1" name=""/>
+        <p:cNvGrpSpPr/>
+        <p:nvPr/>
+      </p:nvGrpSpPr>
+      <p:grpSpPr>
+        <a:xfrm>
+          <a:off x="0" y="0"/>
+          <a:ext cx="0" cy="0"/>
+          <a:chOff x="0" y="0"/>
+          <a:chExt cx="0" cy="0"/>
+        </a:xfrm>
+      </p:grpSpPr>
+      <p:sp>
+        <p:nvSpPr>
+          <p:cNvPr id="2" name="Title 1">
+            <a:extLst>
+              <a:ext uri="{FF2B5EF4-FFF2-40B4-BE49-F238E27FC236}">
+                <a16:creationId xmlns:a16="http://schemas.microsoft.com/office/drawing/2014/main" id="{F31E1842-157E-A99A-6381-F539C7DF0359}"/>
+              </a:ext>
+            </a:extLst>
+          </p:cNvPr>
+          <p:cNvSpPr>
+            <a:spLocks noGrp="1"/>
+          </p:cNvSpPr>
+          <p:nvPr>
+            <p:ph type="title"/>
+          </p:nvPr>
+        </p:nvSpPr>
+        <p:spPr/>
+        <p:txBody>
+          <a:bodyPr/>
+          <a:lstStyle/>
+          <a:p>
+            <a:r>
+              <a:rPr lang="he-IL" dirty="0"/>
+              <a:t>הצעות לשיפור – בחינת התנכסות הפתרון</a:t>
+            </a:r>
+            <a:endParaRPr lang="en-IL" dirty="0"/>
+          </a:p>
+        </p:txBody>
+      </p:sp>
+      <p:sp>
+        <p:nvSpPr>
+          <p:cNvPr id="3" name="Content Placeholder 2">
+            <a:extLst>
+              <a:ext uri="{FF2B5EF4-FFF2-40B4-BE49-F238E27FC236}">
+                <a16:creationId xmlns:a16="http://schemas.microsoft.com/office/drawing/2014/main" id="{2EAFAA93-A889-B90F-390D-B014CB2AA1C4}"/>
+              </a:ext>
+            </a:extLst>
+          </p:cNvPr>
+          <p:cNvSpPr>
+            <a:spLocks noGrp="1"/>
+          </p:cNvSpPr>
+          <p:nvPr>
+            <p:ph idx="1"/>
+          </p:nvPr>
+        </p:nvSpPr>
+        <p:spPr/>
+        <p:txBody>
+          <a:bodyPr/>
+          <a:lstStyle/>
+          <a:p>
+            <a:endParaRPr lang="en-IL" dirty="0"/>
+          </a:p>
+        </p:txBody>
+      </p:sp>
+    </p:spTree>
+    <p:extLst>
+      <p:ext uri="{BB962C8B-B14F-4D97-AF65-F5344CB8AC3E}">
+        <p14:creationId xmlns:p14="http://schemas.microsoft.com/office/powerpoint/2010/main" val="2345178630"/>
+      </p:ext>
+    </p:extLst>
+  </p:cSld>
+  <p:clrMapOvr>
+    <a:masterClrMapping/>
+  </p:clrMapOvr>
+</p:sld>
+</file>
+
+<file path=ppt/slides/slide16.xml><?xml version="1.0" encoding="utf-8"?>
+<p:sld xmlns:a="http://schemas.openxmlformats.org/drawingml/2006/main" xmlns:r="http://schemas.openxmlformats.org/officeDocument/2006/relationships" xmlns:p="http://schemas.openxmlformats.org/presentationml/2006/main">
+  <p:cSld>
+    <p:spTree>
+      <p:nvGrpSpPr>
+        <p:cNvPr id="1" name=""/>
+        <p:cNvGrpSpPr/>
+        <p:nvPr/>
+      </p:nvGrpSpPr>
+      <p:grpSpPr>
+        <a:xfrm>
+          <a:off x="0" y="0"/>
+          <a:ext cx="0" cy="0"/>
+          <a:chOff x="0" y="0"/>
+          <a:chExt cx="0" cy="0"/>
+        </a:xfrm>
+      </p:grpSpPr>
+      <p:sp>
+        <p:nvSpPr>
+          <p:cNvPr id="2" name="Title 1">
+            <a:extLst>
+              <a:ext uri="{FF2B5EF4-FFF2-40B4-BE49-F238E27FC236}">
+                <a16:creationId xmlns:a16="http://schemas.microsoft.com/office/drawing/2014/main" id="{5FC22334-3AB9-72F1-57B4-676978C44507}"/>
+              </a:ext>
+            </a:extLst>
+          </p:cNvPr>
+          <p:cNvSpPr>
+            <a:spLocks noGrp="1"/>
+          </p:cNvSpPr>
+          <p:nvPr>
+            <p:ph type="title"/>
+          </p:nvPr>
+        </p:nvSpPr>
+        <p:spPr/>
+        <p:txBody>
+          <a:bodyPr/>
+          <a:lstStyle/>
+          <a:p>
+            <a:r>
+              <a:rPr lang="he-IL" dirty="0"/>
+              <a:t>הצעות לשיפור – איכון דובר לאתחול פרמטרים</a:t>
+            </a:r>
+            <a:endParaRPr lang="en-IL" dirty="0"/>
+          </a:p>
+        </p:txBody>
+      </p:sp>
+      <p:pic>
+        <p:nvPicPr>
+          <p:cNvPr id="5" name="Content Placeholder 4">
+            <a:extLst>
+              <a:ext uri="{FF2B5EF4-FFF2-40B4-BE49-F238E27FC236}">
+                <a16:creationId xmlns:a16="http://schemas.microsoft.com/office/drawing/2014/main" id="{6AD23705-28A1-6A95-D61E-EADE297F7F6C}"/>
+              </a:ext>
+            </a:extLst>
+          </p:cNvPr>
+          <p:cNvPicPr>
+            <a:picLocks noGrp="1" noChangeAspect="1"/>
+          </p:cNvPicPr>
+          <p:nvPr>
+            <p:ph idx="1"/>
+          </p:nvPr>
+        </p:nvPicPr>
+        <p:blipFill>
+          <a:blip r:embed="rId2"/>
+          <a:stretch>
+            <a:fillRect/>
+          </a:stretch>
+        </p:blipFill>
+        <p:spPr>
+          <a:xfrm>
+            <a:off x="1096171" y="2204200"/>
+            <a:ext cx="4626274" cy="3590425"/>
+          </a:xfrm>
+        </p:spPr>
+      </p:pic>
+      <p:pic>
+        <p:nvPicPr>
+          <p:cNvPr id="7" name="Picture 6">
+            <a:extLst>
+              <a:ext uri="{FF2B5EF4-FFF2-40B4-BE49-F238E27FC236}">
+                <a16:creationId xmlns:a16="http://schemas.microsoft.com/office/drawing/2014/main" id="{5B6823C3-97BA-B3D9-E595-3BE51D56458A}"/>
+              </a:ext>
+            </a:extLst>
+          </p:cNvPr>
+          <p:cNvPicPr>
+            <a:picLocks noChangeAspect="1"/>
+          </p:cNvPicPr>
+          <p:nvPr/>
+        </p:nvPicPr>
+        <p:blipFill>
+          <a:blip r:embed="rId3"/>
+          <a:stretch>
+            <a:fillRect/>
+          </a:stretch>
+        </p:blipFill>
+        <p:spPr>
+          <a:xfrm>
+            <a:off x="6288336" y="2189542"/>
+            <a:ext cx="4807493" cy="3747255"/>
+          </a:xfrm>
+          <a:prstGeom prst="rect">
+            <a:avLst/>
+          </a:prstGeom>
+        </p:spPr>
+      </p:pic>
+    </p:spTree>
+    <p:extLst>
+      <p:ext uri="{BB962C8B-B14F-4D97-AF65-F5344CB8AC3E}">
+        <p14:creationId xmlns:p14="http://schemas.microsoft.com/office/powerpoint/2010/main" val="227767237"/>
       </p:ext>
     </p:extLst>
   </p:cSld>
@@ -7885,7 +9038,16 @@
                                       <a:ea typeface="DengXian" panose="02010600030101010101" pitchFamily="2" charset="-122"/>
                                       <a:cs typeface="Arial" panose="020B0604020202020204" pitchFamily="34" charset="0"/>
                                     </a:rPr>
-                                    <m:t>=0</m:t>
+                                    <m:t>=</m:t>
+                                  </m:r>
+                                  <m:r>
+                                    <a:rPr lang="en-US" sz="1800" i="1" kern="100">
+                                      <a:effectLst/>
+                                      <a:latin typeface="Cambria Math" panose="02040503050406030204" pitchFamily="18" charset="0"/>
+                                      <a:ea typeface="DengXian" panose="02010600030101010101" pitchFamily="2" charset="-122"/>
+                                      <a:cs typeface="Arial" panose="020B0604020202020204" pitchFamily="34" charset="0"/>
+                                    </a:rPr>
+                                    <m:t>0</m:t>
                                   </m:r>
                                 </m:sub>
                                 <m:sup>
@@ -7905,7 +9067,16 @@
                                       <a:ea typeface="DengXian" panose="02010600030101010101" pitchFamily="2" charset="-122"/>
                                       <a:cs typeface="Arial" panose="020B0604020202020204" pitchFamily="34" charset="0"/>
                                     </a:rPr>
-                                    <m:t>−1</m:t>
+                                    <m:t>−</m:t>
+                                  </m:r>
+                                  <m:r>
+                                    <a:rPr lang="en-US" sz="1800" i="1" kern="100">
+                                      <a:effectLst/>
+                                      <a:latin typeface="Cambria Math" panose="02040503050406030204" pitchFamily="18" charset="0"/>
+                                      <a:ea typeface="DengXian" panose="02010600030101010101" pitchFamily="2" charset="-122"/>
+                                      <a:cs typeface="Arial" panose="020B0604020202020204" pitchFamily="34" charset="0"/>
+                                    </a:rPr>
+                                    <m:t>1</m:t>
                                   </m:r>
                                 </m:sup>
                               </m:sSubSup>
@@ -7942,7 +9113,16 @@
                                   <a:ea typeface="DengXian" panose="02010600030101010101" pitchFamily="2" charset="-122"/>
                                   <a:cs typeface="Arial" panose="020B0604020202020204" pitchFamily="34" charset="0"/>
                                 </a:rPr>
-                                <m:t>=0</m:t>
+                                <m:t>=</m:t>
+                              </m:r>
+                              <m:r>
+                                <a:rPr lang="en-US" sz="1800" i="1" kern="100">
+                                  <a:effectLst/>
+                                  <a:latin typeface="Cambria Math" panose="02040503050406030204" pitchFamily="18" charset="0"/>
+                                  <a:ea typeface="DengXian" panose="02010600030101010101" pitchFamily="2" charset="-122"/>
+                                  <a:cs typeface="Arial" panose="020B0604020202020204" pitchFamily="34" charset="0"/>
+                                </a:rPr>
+                                <m:t>0</m:t>
                               </m:r>
                             </m:sub>
                             <m:sup>
@@ -7962,7 +9142,16 @@
                                   <a:ea typeface="DengXian" panose="02010600030101010101" pitchFamily="2" charset="-122"/>
                                   <a:cs typeface="Arial" panose="020B0604020202020204" pitchFamily="34" charset="0"/>
                                 </a:rPr>
-                                <m:t>−1</m:t>
+                                <m:t>−</m:t>
+                              </m:r>
+                              <m:r>
+                                <a:rPr lang="en-US" sz="1800" i="1" kern="100">
+                                  <a:effectLst/>
+                                  <a:latin typeface="Cambria Math" panose="02040503050406030204" pitchFamily="18" charset="0"/>
+                                  <a:ea typeface="DengXian" panose="02010600030101010101" pitchFamily="2" charset="-122"/>
+                                  <a:cs typeface="Arial" panose="020B0604020202020204" pitchFamily="34" charset="0"/>
+                                </a:rPr>
+                                <m:t>1</m:t>
                               </m:r>
                             </m:sup>
                             <m:e>
@@ -8269,7 +9458,25 @@
                           <a:ea typeface="DengXian" panose="02010600030101010101" pitchFamily="2" charset="-122"/>
                           <a:cs typeface="Arial" panose="020B0604020202020204" pitchFamily="34" charset="0"/>
                         </a:rPr>
-                        <m:t>=1+</m:t>
+                        <m:t>=</m:t>
+                      </m:r>
+                      <m:r>
+                        <a:rPr lang="en-US" sz="1800" i="1" kern="100">
+                          <a:effectLst/>
+                          <a:latin typeface="Cambria Math" panose="02040503050406030204" pitchFamily="18" charset="0"/>
+                          <a:ea typeface="DengXian" panose="02010600030101010101" pitchFamily="2" charset="-122"/>
+                          <a:cs typeface="Arial" panose="020B0604020202020204" pitchFamily="34" charset="0"/>
+                        </a:rPr>
+                        <m:t>1</m:t>
+                      </m:r>
+                      <m:r>
+                        <a:rPr lang="en-US" sz="1800" i="1" kern="100">
+                          <a:effectLst/>
+                          <a:latin typeface="Cambria Math" panose="02040503050406030204" pitchFamily="18" charset="0"/>
+                          <a:ea typeface="DengXian" panose="02010600030101010101" pitchFamily="2" charset="-122"/>
+                          <a:cs typeface="Arial" panose="020B0604020202020204" pitchFamily="34" charset="0"/>
+                        </a:rPr>
+                        <m:t>+</m:t>
                       </m:r>
                       <m:sSub>
                         <m:sSubPr>
@@ -8428,7 +9635,25 @@
                           <a:ea typeface="DengXian" panose="02010600030101010101" pitchFamily="2" charset="-122"/>
                           <a:cs typeface="Arial" panose="020B0604020202020204" pitchFamily="34" charset="0"/>
                         </a:rPr>
-                        <m:t>≥0  ∀</m:t>
+                        <m:t>≥</m:t>
+                      </m:r>
+                      <m:r>
+                        <a:rPr lang="en-US" sz="1800" i="1" kern="100">
+                          <a:effectLst/>
+                          <a:latin typeface="Cambria Math" panose="02040503050406030204" pitchFamily="18" charset="0"/>
+                          <a:ea typeface="DengXian" panose="02010600030101010101" pitchFamily="2" charset="-122"/>
+                          <a:cs typeface="Arial" panose="020B0604020202020204" pitchFamily="34" charset="0"/>
+                        </a:rPr>
+                        <m:t>0</m:t>
+                      </m:r>
+                      <m:r>
+                        <a:rPr lang="en-US" sz="1800" i="1" kern="100">
+                          <a:effectLst/>
+                          <a:latin typeface="Cambria Math" panose="02040503050406030204" pitchFamily="18" charset="0"/>
+                          <a:ea typeface="DengXian" panose="02010600030101010101" pitchFamily="2" charset="-122"/>
+                          <a:cs typeface="Arial" panose="020B0604020202020204" pitchFamily="34" charset="0"/>
+                        </a:rPr>
+                        <m:t>  ∀</m:t>
                       </m:r>
                       <m:r>
                         <a:rPr lang="en-US" sz="1800" i="1" kern="100">
@@ -8557,7 +9782,16 @@
                                       <a:ea typeface="DengXian" panose="02010600030101010101" pitchFamily="2" charset="-122"/>
                                       <a:cs typeface="Arial" panose="020B0604020202020204" pitchFamily="34" charset="0"/>
                                     </a:rPr>
-                                    <m:t>−1</m:t>
+                                    <m:t>−</m:t>
+                                  </m:r>
+                                  <m:r>
+                                    <a:rPr lang="en-US" sz="1800" i="1" kern="100">
+                                      <a:effectLst/>
+                                      <a:latin typeface="Cambria Math" panose="02040503050406030204" pitchFamily="18" charset="0"/>
+                                      <a:ea typeface="DengXian" panose="02010600030101010101" pitchFamily="2" charset="-122"/>
+                                      <a:cs typeface="Arial" panose="020B0604020202020204" pitchFamily="34" charset="0"/>
+                                    </a:rPr>
+                                    <m:t>1</m:t>
                                   </m:r>
                                 </m:sup>
                               </m:sSup>
@@ -8617,7 +9851,16 @@
                                               <a:ea typeface="DengXian" panose="02010600030101010101" pitchFamily="2" charset="-122"/>
                                               <a:cs typeface="Arial" panose="020B0604020202020204" pitchFamily="34" charset="0"/>
                                             </a:rPr>
-                                            <m:t>0,</m:t>
+                                            <m:t>0</m:t>
+                                          </m:r>
+                                          <m:r>
+                                            <a:rPr lang="en-US" sz="1800" i="1" kern="100">
+                                              <a:effectLst/>
+                                              <a:latin typeface="Cambria Math" panose="02040503050406030204" pitchFamily="18" charset="0"/>
+                                              <a:ea typeface="DengXian" panose="02010600030101010101" pitchFamily="2" charset="-122"/>
+                                              <a:cs typeface="Arial" panose="020B0604020202020204" pitchFamily="34" charset="0"/>
+                                            </a:rPr>
+                                            <m:t>,</m:t>
                                           </m:r>
                                           <m:r>
                                             <a:rPr lang="en-US" sz="1800" i="1" kern="100">
@@ -8678,7 +9921,25 @@
                                               <a:ea typeface="DengXian" panose="02010600030101010101" pitchFamily="2" charset="-122"/>
                                               <a:cs typeface="Arial" panose="020B0604020202020204" pitchFamily="34" charset="0"/>
                                             </a:rPr>
-                                            <m:t>−1,</m:t>
+                                            <m:t>−</m:t>
+                                          </m:r>
+                                          <m:r>
+                                            <a:rPr lang="en-US" sz="1800" i="1" kern="100">
+                                              <a:effectLst/>
+                                              <a:latin typeface="Cambria Math" panose="02040503050406030204" pitchFamily="18" charset="0"/>
+                                              <a:ea typeface="DengXian" panose="02010600030101010101" pitchFamily="2" charset="-122"/>
+                                              <a:cs typeface="Arial" panose="020B0604020202020204" pitchFamily="34" charset="0"/>
+                                            </a:rPr>
+                                            <m:t>1</m:t>
+                                          </m:r>
+                                          <m:r>
+                                            <a:rPr lang="en-US" sz="1800" i="1" kern="100">
+                                              <a:effectLst/>
+                                              <a:latin typeface="Cambria Math" panose="02040503050406030204" pitchFamily="18" charset="0"/>
+                                              <a:ea typeface="DengXian" panose="02010600030101010101" pitchFamily="2" charset="-122"/>
+                                              <a:cs typeface="Arial" panose="020B0604020202020204" pitchFamily="34" charset="0"/>
+                                            </a:rPr>
+                                            <m:t>,</m:t>
                                           </m:r>
                                           <m:r>
                                             <a:rPr lang="en-US" sz="1800" i="1" kern="100">
@@ -8728,7 +9989,25 @@
                           <a:ea typeface="DengXian" panose="02010600030101010101" pitchFamily="2" charset="-122"/>
                           <a:cs typeface="Arial" panose="020B0604020202020204" pitchFamily="34" charset="0"/>
                         </a:rPr>
-                        <m:t>=0,  ∀</m:t>
+                        <m:t>=</m:t>
+                      </m:r>
+                      <m:r>
+                        <a:rPr lang="en-US" sz="1800" i="1" kern="100">
+                          <a:effectLst/>
+                          <a:latin typeface="Cambria Math" panose="02040503050406030204" pitchFamily="18" charset="0"/>
+                          <a:ea typeface="DengXian" panose="02010600030101010101" pitchFamily="2" charset="-122"/>
+                          <a:cs typeface="Arial" panose="020B0604020202020204" pitchFamily="34" charset="0"/>
+                        </a:rPr>
+                        <m:t>0</m:t>
+                      </m:r>
+                      <m:r>
+                        <a:rPr lang="en-US" sz="1800" i="1" kern="100">
+                          <a:effectLst/>
+                          <a:latin typeface="Cambria Math" panose="02040503050406030204" pitchFamily="18" charset="0"/>
+                          <a:ea typeface="DengXian" panose="02010600030101010101" pitchFamily="2" charset="-122"/>
+                          <a:cs typeface="Arial" panose="020B0604020202020204" pitchFamily="34" charset="0"/>
+                        </a:rPr>
+                        <m:t>,  ∀</m:t>
                       </m:r>
                       <m:r>
                         <a:rPr lang="en-US" sz="1800" i="1" kern="100">
@@ -9457,7 +10736,16 @@
                             <a:ea typeface="DengXian" panose="02010600030101010101" pitchFamily="2" charset="-122"/>
                             <a:cs typeface="Arial" panose="020B0604020202020204" pitchFamily="34" charset="0"/>
                           </a:rPr>
-                          <m:t>−1</m:t>
+                          <m:t>−</m:t>
+                        </m:r>
+                        <m:r>
+                          <a:rPr lang="en-US" sz="1800" i="1" kern="100">
+                            <a:effectLst/>
+                            <a:latin typeface="Cambria Math" panose="02040503050406030204" pitchFamily="18" charset="0"/>
+                            <a:ea typeface="DengXian" panose="02010600030101010101" pitchFamily="2" charset="-122"/>
+                            <a:cs typeface="Arial" panose="020B0604020202020204" pitchFamily="34" charset="0"/>
+                          </a:rPr>
+                          <m:t>1</m:t>
                         </m:r>
                       </m:e>
                     </m:d>
@@ -9589,8 +10877,8 @@
           </a:p>
         </p:txBody>
       </p:sp>
-      <mc:AlternateContent xmlns:mc="http://schemas.openxmlformats.org/markup-compatibility/2006">
-        <mc:Choice xmlns:a14="http://schemas.microsoft.com/office/drawing/2010/main" Requires="a14">
+      <mc:AlternateContent xmlns:mc="http://schemas.openxmlformats.org/markup-compatibility/2006" xmlns:a14="http://schemas.microsoft.com/office/drawing/2010/main">
+        <mc:Choice Requires="a14">
           <p:sp>
             <p:nvSpPr>
               <p:cNvPr id="3" name="Content Placeholder 2">
@@ -9931,7 +11219,7 @@
             </p:txBody>
           </p:sp>
         </mc:Choice>
-        <mc:Fallback>
+        <mc:Fallback xmlns="">
           <p:sp>
             <p:nvSpPr>
               <p:cNvPr id="3" name="Content Placeholder 2">
@@ -10041,8 +11329,8 @@
           </a:p>
         </p:txBody>
       </p:sp>
-      <mc:AlternateContent xmlns:mc="http://schemas.openxmlformats.org/markup-compatibility/2006">
-        <mc:Choice xmlns:a14="http://schemas.microsoft.com/office/drawing/2010/main" Requires="a14">
+      <mc:AlternateContent xmlns:mc="http://schemas.openxmlformats.org/markup-compatibility/2006" xmlns:a14="http://schemas.microsoft.com/office/drawing/2010/main">
+        <mc:Choice Requires="a14">
           <p:sp>
             <p:nvSpPr>
               <p:cNvPr id="3" name="Content Placeholder 2">
@@ -10248,7 +11536,16 @@
                             <a:ea typeface="DengXian" panose="02010600030101010101" pitchFamily="2" charset="-122"/>
                             <a:cs typeface="Arial" panose="020B0604020202020204" pitchFamily="34" charset="0"/>
                           </a:rPr>
-                          <m:t>−1</m:t>
+                          <m:t>−</m:t>
+                        </m:r>
+                        <m:r>
+                          <a:rPr lang="en-US" b="0" i="1" kern="100" dirty="0" smtClean="0">
+                            <a:effectLst/>
+                            <a:latin typeface="Cambria Math" panose="02040503050406030204" pitchFamily="18" charset="0"/>
+                            <a:ea typeface="DengXian" panose="02010600030101010101" pitchFamily="2" charset="-122"/>
+                            <a:cs typeface="Arial" panose="020B0604020202020204" pitchFamily="34" charset="0"/>
+                          </a:rPr>
+                          <m:t>1</m:t>
                         </m:r>
                       </m:e>
                     </m:d>
@@ -10526,7 +11823,16 @@
                                   <a:ea typeface="DengXian" panose="02010600030101010101" pitchFamily="2" charset="-122"/>
                                   <a:cs typeface="Arial" panose="020B0604020202020204" pitchFamily="34" charset="0"/>
                                 </a:rPr>
-                                <m:t>0   </m:t>
+                                <m:t>0</m:t>
+                              </m:r>
+                              <m:r>
+                                <a:rPr lang="en-US" b="0" i="1" kern="100" dirty="0" smtClean="0">
+                                  <a:effectLst/>
+                                  <a:latin typeface="Cambria Math" panose="02040503050406030204" pitchFamily="18" charset="0"/>
+                                  <a:ea typeface="DengXian" panose="02010600030101010101" pitchFamily="2" charset="-122"/>
+                                  <a:cs typeface="Arial" panose="020B0604020202020204" pitchFamily="34" charset="0"/>
+                                </a:rPr>
+                                <m:t>   </m:t>
                               </m:r>
                               <m:d>
                                 <m:dPr>
@@ -10674,7 +11980,16 @@
                         <a:ea typeface="DengXian" panose="02010600030101010101" pitchFamily="2" charset="-122"/>
                         <a:cs typeface="Arial" panose="020B0604020202020204" pitchFamily="34" charset="0"/>
                       </a:rPr>
-                      <m:t>≥0</m:t>
+                      <m:t>≥</m:t>
+                    </m:r>
+                    <m:r>
+                      <a:rPr lang="en-US" i="1" kern="100">
+                        <a:effectLst/>
+                        <a:latin typeface="Cambria Math" panose="02040503050406030204" pitchFamily="18" charset="0"/>
+                        <a:ea typeface="DengXian" panose="02010600030101010101" pitchFamily="2" charset="-122"/>
+                        <a:cs typeface="Arial" panose="020B0604020202020204" pitchFamily="34" charset="0"/>
+                      </a:rPr>
+                      <m:t>0</m:t>
                     </m:r>
                   </m:oMath>
                 </a14:m>
@@ -10710,7 +12025,7 @@
             </p:txBody>
           </p:sp>
         </mc:Choice>
-        <mc:Fallback>
+        <mc:Fallback xmlns="">
           <p:sp>
             <p:nvSpPr>
               <p:cNvPr id="3" name="Content Placeholder 2">

</xml_diff>